<commit_message>
Apply the slide-3 rework surgically, on his save, the moment the lock cleared
His session edit was a reposition/resize of the explainer image - the pixels
were swapped INSIDE the existing media part, so his frame stands untouched at
7.65 x 1.42 in. The first run aborted on its own guard: 'exactly one picture'
was wrong from the start, because every slide carries the JU logo as a picture
too - the explainer is now selected by media identity (2360x590), not count.
Cards 1 and 2 reworded at run level; his third card untouched. Of his 19 slides,
changed: [3].

Co-Authored-By: Claude Fable 5 <noreply@anthropic.com>
</commit_message>
<xml_diff>
--- a/documentation/decks/PPD_Final_Presentation.pptx
+++ b/documentation/decks/PPD_Final_Presentation.pptx
@@ -157,7 +157,7 @@
   <pc:docChgLst>
     <pc:chgData name="Adithya Sivakumar" userId="66f9b287-a2d3-4cb5-8dae-29884e733115" providerId="ADAL" clId="{937D3A49-D0E7-486D-BA98-5AD23D3FA812}"/>
     <pc:docChg chg="undo redo custSel addSld delSld modSld modMainMaster">
-      <pc:chgData name="Adithya Sivakumar" userId="66f9b287-a2d3-4cb5-8dae-29884e733115" providerId="ADAL" clId="{937D3A49-D0E7-486D-BA98-5AD23D3FA812}" dt="2026-09-04T17:25:34.983" v="137" actId="22"/>
+      <pc:chgData name="Adithya Sivakumar" userId="66f9b287-a2d3-4cb5-8dae-29884e733115" providerId="ADAL" clId="{937D3A49-D0E7-486D-BA98-5AD23D3FA812}" dt="2026-09-05T12:38:29.965" v="173" actId="1076"/>
       <pc:docMkLst>
         <pc:docMk/>
       </pc:docMkLst>
@@ -383,6 +383,53 @@
           </ac:spMkLst>
         </pc:spChg>
       </pc:sldChg>
+      <pc:sldChg chg="modSp mod">
+        <pc:chgData name="Adithya Sivakumar" userId="66f9b287-a2d3-4cb5-8dae-29884e733115" providerId="ADAL" clId="{937D3A49-D0E7-486D-BA98-5AD23D3FA812}" dt="2026-09-05T12:38:29.965" v="173" actId="1076"/>
+        <pc:sldMkLst>
+          <pc:docMk/>
+          <pc:sldMk cId="0" sldId="258"/>
+        </pc:sldMkLst>
+        <pc:spChg chg="mod">
+          <ac:chgData name="Adithya Sivakumar" userId="66f9b287-a2d3-4cb5-8dae-29884e733115" providerId="ADAL" clId="{937D3A49-D0E7-486D-BA98-5AD23D3FA812}" dt="2026-09-05T11:20:16.156" v="144" actId="14100"/>
+          <ac:spMkLst>
+            <pc:docMk/>
+            <pc:sldMk cId="0" sldId="258"/>
+            <ac:spMk id="16" creationId="{00000000-0000-0000-0000-000000000000}"/>
+          </ac:spMkLst>
+        </pc:spChg>
+        <pc:spChg chg="mod">
+          <ac:chgData name="Adithya Sivakumar" userId="66f9b287-a2d3-4cb5-8dae-29884e733115" providerId="ADAL" clId="{937D3A49-D0E7-486D-BA98-5AD23D3FA812}" dt="2026-09-05T11:19:50.508" v="143" actId="1076"/>
+          <ac:spMkLst>
+            <pc:docMk/>
+            <pc:sldMk cId="0" sldId="258"/>
+            <ac:spMk id="17" creationId="{00000000-0000-0000-0000-000000000000}"/>
+          </ac:spMkLst>
+        </pc:spChg>
+        <pc:spChg chg="mod">
+          <ac:chgData name="Adithya Sivakumar" userId="66f9b287-a2d3-4cb5-8dae-29884e733115" providerId="ADAL" clId="{937D3A49-D0E7-486D-BA98-5AD23D3FA812}" dt="2026-09-05T11:32:34.991" v="153" actId="20577"/>
+          <ac:spMkLst>
+            <pc:docMk/>
+            <pc:sldMk cId="0" sldId="258"/>
+            <ac:spMk id="29" creationId="{00000000-0000-0000-0000-000000000000}"/>
+          </ac:spMkLst>
+        </pc:spChg>
+        <pc:spChg chg="mod">
+          <ac:chgData name="Adithya Sivakumar" userId="66f9b287-a2d3-4cb5-8dae-29884e733115" providerId="ADAL" clId="{937D3A49-D0E7-486D-BA98-5AD23D3FA812}" dt="2026-09-05T11:33:00.493" v="171" actId="20577"/>
+          <ac:spMkLst>
+            <pc:docMk/>
+            <pc:sldMk cId="0" sldId="258"/>
+            <ac:spMk id="30" creationId="{00000000-0000-0000-0000-000000000000}"/>
+          </ac:spMkLst>
+        </pc:spChg>
+        <pc:picChg chg="mod">
+          <ac:chgData name="Adithya Sivakumar" userId="66f9b287-a2d3-4cb5-8dae-29884e733115" providerId="ADAL" clId="{937D3A49-D0E7-486D-BA98-5AD23D3FA812}" dt="2026-09-05T12:38:29.965" v="173" actId="1076"/>
+          <ac:picMkLst>
+            <pc:docMk/>
+            <pc:sldMk cId="0" sldId="258"/>
+            <ac:picMk id="18" creationId="{00000000-0000-0000-0000-000000000000}"/>
+          </ac:picMkLst>
+        </pc:picChg>
+      </pc:sldChg>
       <pc:sldChg chg="new del">
         <pc:chgData name="Adithya Sivakumar" userId="66f9b287-a2d3-4cb5-8dae-29884e733115" providerId="ADAL" clId="{937D3A49-D0E7-486D-BA98-5AD23D3FA812}" dt="2026-09-04T17:18:09.441" v="50" actId="680"/>
         <pc:sldMkLst>
@@ -492,7 +539,7 @@
           <a:p>
             <a:fld id="{9365FE33-248B-418E-80DF-32EE702ADF6F}" type="datetimeFigureOut">
               <a:rPr lang="en-SE" smtClean="0"/>
-              <a:t>2026-09-04</a:t>
+              <a:t>2026-09-05</a:t>
             </a:fld>
             <a:endParaRPr lang="en-SE"/>
           </a:p>
@@ -844,6 +891,90 @@
 </p:notes>
 </file>
 
+<file path=ppt/notesSlides/notesSlide2.xml><?xml version="1.0" encoding="utf-8"?>
+<p:notes xmlns:a="http://schemas.openxmlformats.org/drawingml/2006/main" xmlns:r="http://schemas.openxmlformats.org/officeDocument/2006/relationships" xmlns:p="http://schemas.openxmlformats.org/presentationml/2006/main">
+  <p:cSld>
+    <p:spTree>
+      <p:nvGrpSpPr>
+        <p:cNvPr id="1" name=""/>
+        <p:cNvGrpSpPr/>
+        <p:nvPr/>
+      </p:nvGrpSpPr>
+      <p:grpSpPr>
+        <a:xfrm>
+          <a:off x="0" y="0"/>
+          <a:ext cx="0" cy="0"/>
+          <a:chOff x="0" y="0"/>
+          <a:chExt cx="0" cy="0"/>
+        </a:xfrm>
+      </p:grpSpPr>
+      <p:sp>
+        <p:nvSpPr>
+          <p:cNvPr id="2" name="Slide Image Placeholder 1"/>
+          <p:cNvSpPr>
+            <a:spLocks noGrp="1" noRot="1" noChangeAspect="1"/>
+          </p:cNvSpPr>
+          <p:nvPr>
+            <p:ph type="sldImg"/>
+          </p:nvPr>
+        </p:nvSpPr>
+        <p:spPr/>
+      </p:sp>
+      <p:sp>
+        <p:nvSpPr>
+          <p:cNvPr id="3" name="Notes Placeholder 2"/>
+          <p:cNvSpPr>
+            <a:spLocks noGrp="1"/>
+          </p:cNvSpPr>
+          <p:nvPr>
+            <p:ph type="body" idx="1"/>
+          </p:nvPr>
+        </p:nvSpPr>
+        <p:spPr/>
+        <p:txBody>
+          <a:bodyPr/>
+          <a:lstStyle/>
+          <a:p>
+            <a:endParaRPr lang="en-SE" dirty="0"/>
+          </a:p>
+        </p:txBody>
+      </p:sp>
+      <p:sp>
+        <p:nvSpPr>
+          <p:cNvPr id="4" name="Slide Number Placeholder 3"/>
+          <p:cNvSpPr>
+            <a:spLocks noGrp="1"/>
+          </p:cNvSpPr>
+          <p:nvPr>
+            <p:ph type="sldNum" sz="quarter" idx="5"/>
+          </p:nvPr>
+        </p:nvSpPr>
+        <p:spPr/>
+        <p:txBody>
+          <a:bodyPr/>
+          <a:lstStyle/>
+          <a:p>
+            <a:fld id="{3973D6B5-9C92-4220-B47A-53362BAF60D8}" type="slidenum">
+              <a:rPr lang="en-SE" smtClean="0"/>
+              <a:t>4</a:t>
+            </a:fld>
+            <a:endParaRPr lang="en-SE"/>
+          </a:p>
+        </p:txBody>
+      </p:sp>
+    </p:spTree>
+    <p:extLst>
+      <p:ext uri="{BB962C8B-B14F-4D97-AF65-F5344CB8AC3E}">
+        <p14:creationId xmlns:p14="http://schemas.microsoft.com/office/powerpoint/2010/main" val="1100821083"/>
+      </p:ext>
+    </p:extLst>
+  </p:cSld>
+  <p:clrMapOvr>
+    <a:masterClrMapping/>
+  </p:clrMapOvr>
+</p:notes>
+</file>
+
 <file path=ppt/slideLayouts/slideLayout1.xml><?xml version="1.0" encoding="utf-8"?>
 <p:sldLayout xmlns:a="http://schemas.openxmlformats.org/drawingml/2006/main" xmlns:r="http://schemas.openxmlformats.org/officeDocument/2006/relationships" xmlns:p="http://schemas.openxmlformats.org/presentationml/2006/main" type="title" preserve="1">
   <p:cSld name="Title Slide">
@@ -1023,7 +1154,7 @@
           <a:p>
             <a:fld id="{5BCAD085-E8A6-8845-BD4E-CB4CCA059FC4}" type="datetimeFigureOut">
               <a:rPr lang="en-US" smtClean="0"/>
-              <a:t>9/4/2026</a:t>
+              <a:t>9/5/2026</a:t>
             </a:fld>
             <a:endParaRPr lang="en-US"/>
           </a:p>
@@ -1191,7 +1322,7 @@
           <a:p>
             <a:fld id="{5BCAD085-E8A6-8845-BD4E-CB4CCA059FC4}" type="datetimeFigureOut">
               <a:rPr lang="en-US" smtClean="0"/>
-              <a:t>9/4/2026</a:t>
+              <a:t>9/5/2026</a:t>
             </a:fld>
             <a:endParaRPr lang="en-US"/>
           </a:p>
@@ -1369,7 +1500,7 @@
           <a:p>
             <a:fld id="{5BCAD085-E8A6-8845-BD4E-CB4CCA059FC4}" type="datetimeFigureOut">
               <a:rPr lang="en-US" smtClean="0"/>
-              <a:t>9/4/2026</a:t>
+              <a:t>9/5/2026</a:t>
             </a:fld>
             <a:endParaRPr lang="en-US"/>
           </a:p>
@@ -1537,7 +1668,7 @@
           <a:p>
             <a:fld id="{5BCAD085-E8A6-8845-BD4E-CB4CCA059FC4}" type="datetimeFigureOut">
               <a:rPr lang="en-US" smtClean="0"/>
-              <a:t>9/4/2026</a:t>
+              <a:t>9/5/2026</a:t>
             </a:fld>
             <a:endParaRPr lang="en-US"/>
           </a:p>
@@ -1782,7 +1913,7 @@
           <a:p>
             <a:fld id="{5BCAD085-E8A6-8845-BD4E-CB4CCA059FC4}" type="datetimeFigureOut">
               <a:rPr lang="en-US" smtClean="0"/>
-              <a:t>9/4/2026</a:t>
+              <a:t>9/5/2026</a:t>
             </a:fld>
             <a:endParaRPr lang="en-US"/>
           </a:p>
@@ -2067,7 +2198,7 @@
           <a:p>
             <a:fld id="{5BCAD085-E8A6-8845-BD4E-CB4CCA059FC4}" type="datetimeFigureOut">
               <a:rPr lang="en-US" smtClean="0"/>
-              <a:t>9/4/2026</a:t>
+              <a:t>9/5/2026</a:t>
             </a:fld>
             <a:endParaRPr lang="en-US"/>
           </a:p>
@@ -2486,7 +2617,7 @@
           <a:p>
             <a:fld id="{5BCAD085-E8A6-8845-BD4E-CB4CCA059FC4}" type="datetimeFigureOut">
               <a:rPr lang="en-US" smtClean="0"/>
-              <a:t>9/4/2026</a:t>
+              <a:t>9/5/2026</a:t>
             </a:fld>
             <a:endParaRPr lang="en-US"/>
           </a:p>
@@ -2603,7 +2734,7 @@
           <a:p>
             <a:fld id="{5BCAD085-E8A6-8845-BD4E-CB4CCA059FC4}" type="datetimeFigureOut">
               <a:rPr lang="en-US" smtClean="0"/>
-              <a:t>9/4/2026</a:t>
+              <a:t>9/5/2026</a:t>
             </a:fld>
             <a:endParaRPr lang="en-US"/>
           </a:p>
@@ -2698,7 +2829,7 @@
           <a:p>
             <a:fld id="{5BCAD085-E8A6-8845-BD4E-CB4CCA059FC4}" type="datetimeFigureOut">
               <a:rPr lang="en-US" smtClean="0"/>
-              <a:t>9/4/2026</a:t>
+              <a:t>9/5/2026</a:t>
             </a:fld>
             <a:endParaRPr lang="en-US"/>
           </a:p>
@@ -2973,7 +3104,7 @@
           <a:p>
             <a:fld id="{5BCAD085-E8A6-8845-BD4E-CB4CCA059FC4}" type="datetimeFigureOut">
               <a:rPr lang="en-US" smtClean="0"/>
-              <a:t>9/4/2026</a:t>
+              <a:t>9/5/2026</a:t>
             </a:fld>
             <a:endParaRPr lang="en-US"/>
           </a:p>
@@ -3225,7 +3356,7 @@
           <a:p>
             <a:fld id="{5BCAD085-E8A6-8845-BD4E-CB4CCA059FC4}" type="datetimeFigureOut">
               <a:rPr lang="en-US" smtClean="0"/>
-              <a:t>9/4/2026</a:t>
+              <a:t>9/5/2026</a:t>
             </a:fld>
             <a:endParaRPr lang="en-US"/>
           </a:p>
@@ -3436,7 +3567,7 @@
           <a:p>
             <a:fld id="{5BCAD085-E8A6-8845-BD4E-CB4CCA059FC4}" type="datetimeFigureOut">
               <a:rPr lang="en-US" smtClean="0"/>
-              <a:t>9/4/2026</a:t>
+              <a:t>9/5/2026</a:t>
             </a:fld>
             <a:endParaRPr lang="en-US"/>
           </a:p>
@@ -18558,6 +18689,7 @@
           <a:lstStyle/>
           <a:p>
             <a:pPr algn="ctr"/>
+            <a:endParaRPr/>
           </a:p>
         </p:txBody>
       </p:sp>
@@ -18602,6 +18734,7 @@
           <a:lstStyle/>
           <a:p>
             <a:pPr algn="ctr"/>
+            <a:endParaRPr/>
           </a:p>
         </p:txBody>
       </p:sp>
@@ -18646,6 +18779,7 @@
           <a:lstStyle/>
           <a:p>
             <a:pPr algn="ctr"/>
+            <a:endParaRPr/>
           </a:p>
         </p:txBody>
       </p:sp>
@@ -18714,6 +18848,7 @@
           <a:lstStyle/>
           <a:p>
             <a:pPr algn="ctr"/>
+            <a:endParaRPr/>
           </a:p>
         </p:txBody>
       </p:sp>
@@ -18758,6 +18893,7 @@
           <a:lstStyle/>
           <a:p>
             <a:pPr algn="ctr"/>
+            <a:endParaRPr/>
           </a:p>
         </p:txBody>
       </p:sp>
@@ -18802,6 +18938,7 @@
           <a:lstStyle/>
           <a:p>
             <a:pPr algn="ctr"/>
+            <a:endParaRPr/>
           </a:p>
         </p:txBody>
       </p:sp>
@@ -18822,7 +18959,7 @@
           <a:noFill/>
         </p:spPr>
         <p:txBody>
-          <a:bodyPr wrap="square" anchor="t" lIns="0" rIns="0" tIns="0" bIns="0">
+          <a:bodyPr wrap="square" lIns="0" tIns="0" rIns="0" bIns="0" anchor="t">
             <a:spAutoFit/>
           </a:bodyPr>
           <a:lstStyle/>
@@ -18861,7 +18998,7 @@
           <a:noFill/>
         </p:spPr>
         <p:txBody>
-          <a:bodyPr wrap="square" anchor="t" lIns="0" rIns="0" tIns="0" bIns="0">
+          <a:bodyPr wrap="square" lIns="0" tIns="0" rIns="0" bIns="0" anchor="t">
             <a:spAutoFit/>
           </a:bodyPr>
           <a:lstStyle/>
@@ -18924,6 +19061,7 @@
           <a:lstStyle/>
           <a:p>
             <a:pPr algn="ctr"/>
+            <a:endParaRPr/>
           </a:p>
         </p:txBody>
       </p:sp>
@@ -18968,6 +19106,7 @@
           <a:lstStyle/>
           <a:p>
             <a:pPr algn="ctr"/>
+            <a:endParaRPr/>
           </a:p>
         </p:txBody>
       </p:sp>
@@ -19012,6 +19151,7 @@
           <a:lstStyle/>
           <a:p>
             <a:pPr algn="ctr"/>
+            <a:endParaRPr/>
           </a:p>
         </p:txBody>
       </p:sp>
@@ -19032,7 +19172,7 @@
           <a:noFill/>
         </p:spPr>
         <p:txBody>
-          <a:bodyPr wrap="none" anchor="t" lIns="0" rIns="0" tIns="0" bIns="0">
+          <a:bodyPr wrap="none" lIns="0" tIns="0" rIns="0" bIns="0" anchor="t">
             <a:spAutoFit/>
           </a:bodyPr>
           <a:lstStyle/>
@@ -19071,7 +19211,7 @@
           <a:noFill/>
         </p:spPr>
         <p:txBody>
-          <a:bodyPr wrap="square" anchor="t" lIns="0" rIns="0" tIns="0" bIns="0">
+          <a:bodyPr wrap="square" lIns="0" tIns="0" rIns="0" bIns="0" anchor="t">
             <a:spAutoFit/>
           </a:bodyPr>
           <a:lstStyle/>
@@ -19102,7 +19242,7 @@
         <p:spPr>
           <a:xfrm>
             <a:off x="777240" y="1810512"/>
-            <a:ext cx="10607040" cy="365760"/>
+            <a:ext cx="10712196" cy="184666"/>
           </a:xfrm>
           <a:prstGeom prst="rect">
             <a:avLst/>
@@ -19110,7 +19250,7 @@
           <a:noFill/>
         </p:spPr>
         <p:txBody>
-          <a:bodyPr wrap="square" anchor="t" lIns="0" rIns="0" tIns="0" bIns="0">
+          <a:bodyPr wrap="square" lIns="0" tIns="0" rIns="0" bIns="0" anchor="t">
             <a:spAutoFit/>
           </a:bodyPr>
           <a:lstStyle/>
@@ -19121,7 +19261,7 @@
               </a:lnSpc>
             </a:pPr>
             <a:r>
-              <a:rPr sz="1200" b="0" i="0">
+              <a:rPr sz="1200" b="0" i="0" dirty="0">
                 <a:solidFill>
                   <a:srgbClr val="253439"/>
                 </a:solidFill>
@@ -19140,8 +19280,8 @@
         </p:nvSpPr>
         <p:spPr>
           <a:xfrm>
-            <a:off x="2258568" y="2304288"/>
-            <a:ext cx="7680960" cy="2240280"/>
+            <a:off x="2328519" y="2578608"/>
+            <a:ext cx="7680960" cy="1623656"/>
           </a:xfrm>
           <a:prstGeom prst="rect">
             <a:avLst/>
@@ -19175,6 +19315,7 @@
           <a:lstStyle/>
           <a:p>
             <a:pPr algn="ctr"/>
+            <a:endParaRPr/>
           </a:p>
         </p:txBody>
       </p:sp>
@@ -19194,8 +19335,8 @@
         </p:blipFill>
         <p:spPr>
           <a:xfrm>
-            <a:off x="2350008" y="2487168"/>
-            <a:ext cx="7498080" cy="1874520"/>
+            <a:off x="2515891" y="2739621"/>
+            <a:ext cx="6992775" cy="1301630"/>
           </a:xfrm>
           <a:prstGeom prst="rect">
             <a:avLst/>
@@ -19245,6 +19386,7 @@
           <a:lstStyle/>
           <a:p>
             <a:pPr algn="ctr"/>
+            <a:endParaRPr/>
           </a:p>
         </p:txBody>
       </p:sp>
@@ -19289,6 +19431,7 @@
           <a:lstStyle/>
           <a:p>
             <a:pPr algn="ctr"/>
+            <a:endParaRPr/>
           </a:p>
         </p:txBody>
       </p:sp>
@@ -19309,7 +19452,7 @@
           <a:noFill/>
         </p:spPr>
         <p:txBody>
-          <a:bodyPr wrap="square" anchor="t" lIns="0" rIns="0" tIns="0" bIns="0">
+          <a:bodyPr wrap="square" lIns="0" tIns="0" rIns="0" bIns="0" anchor="t">
             <a:spAutoFit/>
           </a:bodyPr>
           <a:lstStyle/>
@@ -19348,7 +19491,7 @@
           <a:noFill/>
         </p:spPr>
         <p:txBody>
-          <a:bodyPr wrap="square" anchor="t" lIns="0" rIns="0" tIns="0" bIns="0">
+          <a:bodyPr wrap="square" lIns="0" tIns="0" rIns="0" bIns="0" anchor="t">
             <a:spAutoFit/>
           </a:bodyPr>
           <a:lstStyle/>
@@ -19365,7 +19508,7 @@
                 </a:solidFill>
                 <a:latin typeface="Segoe UI"/>
               </a:rPr>
-              <a:t>nothing touches the specimen — no clip-on gauge to knock off at fracture</a:t>
+              <a:t>no strain gauge glued on, no clip-on extensometer — nothing touches the specimen</a:t>
             </a:r>
           </a:p>
         </p:txBody>
@@ -19413,6 +19556,7 @@
           <a:lstStyle/>
           <a:p>
             <a:pPr algn="ctr"/>
+            <a:endParaRPr/>
           </a:p>
         </p:txBody>
       </p:sp>
@@ -19457,6 +19601,7 @@
           <a:lstStyle/>
           <a:p>
             <a:pPr algn="ctr"/>
+            <a:endParaRPr/>
           </a:p>
         </p:txBody>
       </p:sp>
@@ -19477,7 +19622,7 @@
           <a:noFill/>
         </p:spPr>
         <p:txBody>
-          <a:bodyPr wrap="square" anchor="t" lIns="0" rIns="0" tIns="0" bIns="0">
+          <a:bodyPr wrap="square" lIns="0" tIns="0" rIns="0" bIns="0" anchor="t">
             <a:spAutoFit/>
           </a:bodyPr>
           <a:lstStyle/>
@@ -19494,7 +19639,7 @@
                 </a:solidFill>
                 <a:latin typeface="Segoe UI Semibold"/>
               </a:rPr>
-              <a:t>No calibration</a:t>
+              <a:t>Live stress–strain</a:t>
             </a:r>
           </a:p>
         </p:txBody>
@@ -19516,7 +19661,7 @@
           <a:noFill/>
         </p:spPr>
         <p:txBody>
-          <a:bodyPr wrap="square" anchor="t" lIns="0" rIns="0" tIns="0" bIns="0">
+          <a:bodyPr wrap="square" lIns="0" tIns="0" rIns="0" bIns="0" anchor="t">
             <a:spAutoFit/>
           </a:bodyPr>
           <a:lstStyle/>
@@ -19533,7 +19678,7 @@
                 </a:solidFill>
                 <a:latin typeface="Segoe UI"/>
               </a:rPr>
-              <a:t>strain is a ratio of two pixel distances — mm per pixel cancels out</a:t>
+              <a:t>the load cell gives force, the camera gives strain — the stress–strain curve draws itself live during the pull</a:t>
             </a:r>
           </a:p>
         </p:txBody>
@@ -19581,6 +19726,7 @@
           <a:lstStyle/>
           <a:p>
             <a:pPr algn="ctr"/>
+            <a:endParaRPr/>
           </a:p>
         </p:txBody>
       </p:sp>
@@ -19625,6 +19771,7 @@
           <a:lstStyle/>
           <a:p>
             <a:pPr algn="ctr"/>
+            <a:endParaRPr/>
           </a:p>
         </p:txBody>
       </p:sp>
@@ -19637,7 +19784,7 @@
         <p:spPr>
           <a:xfrm>
             <a:off x="8229600" y="5001768"/>
-            <a:ext cx="3017520" cy="320040"/>
+            <a:ext cx="3017520" cy="207749"/>
           </a:xfrm>
           <a:prstGeom prst="rect">
             <a:avLst/>
@@ -19645,7 +19792,7 @@
           <a:noFill/>
         </p:spPr>
         <p:txBody>
-          <a:bodyPr wrap="square" anchor="t" lIns="0" rIns="0" tIns="0" bIns="0">
+          <a:bodyPr wrap="square" lIns="0" tIns="0" rIns="0" bIns="0" anchor="t">
             <a:spAutoFit/>
           </a:bodyPr>
           <a:lstStyle/>
@@ -19656,7 +19803,7 @@
               </a:lnSpc>
             </a:pPr>
             <a:r>
-              <a:rPr sz="1350" b="0" i="0">
+              <a:rPr sz="1350" b="0" i="0" dirty="0">
                 <a:solidFill>
                   <a:srgbClr val="253439"/>
                 </a:solidFill>
@@ -19664,6 +19811,21 @@
               </a:rPr>
               <a:t>Every frame</a:t>
             </a:r>
+            <a:r>
+              <a:rPr lang="en-GB" sz="1350" b="0" i="0" dirty="0">
+                <a:solidFill>
+                  <a:srgbClr val="253439"/>
+                </a:solidFill>
+                <a:latin typeface="Segoe UI Semibold"/>
+              </a:rPr>
+              <a:t> captured</a:t>
+            </a:r>
+            <a:endParaRPr sz="1350" b="0" i="0" dirty="0">
+              <a:solidFill>
+                <a:srgbClr val="253439"/>
+              </a:solidFill>
+              <a:latin typeface="Segoe UI Semibold"/>
+            </a:endParaRPr>
           </a:p>
         </p:txBody>
       </p:sp>
@@ -19676,7 +19838,7 @@
         <p:spPr>
           <a:xfrm>
             <a:off x="8229600" y="5349240"/>
-            <a:ext cx="3017520" cy="777240"/>
+            <a:ext cx="3017520" cy="327397"/>
           </a:xfrm>
           <a:prstGeom prst="rect">
             <a:avLst/>
@@ -19684,7 +19846,7 @@
           <a:noFill/>
         </p:spPr>
         <p:txBody>
-          <a:bodyPr wrap="square" anchor="t" lIns="0" rIns="0" tIns="0" bIns="0">
+          <a:bodyPr wrap="square" lIns="0" tIns="0" rIns="0" bIns="0" anchor="t">
             <a:spAutoFit/>
           </a:bodyPr>
           <a:lstStyle/>
@@ -19695,13 +19857,49 @@
               </a:lnSpc>
             </a:pPr>
             <a:r>
-              <a:rPr sz="1050" b="0" i="0">
+              <a:rPr sz="1050" b="0" i="0" dirty="0">
                 <a:solidFill>
                   <a:srgbClr val="253439"/>
                 </a:solidFill>
                 <a:latin typeface="Segoe UI"/>
               </a:rPr>
-              <a:t>35 measurements per second, live on screen while the test runs</a:t>
+              <a:t>35 </a:t>
+            </a:r>
+            <a:r>
+              <a:rPr lang="en-GB" sz="1050" b="0" i="0" dirty="0">
+                <a:solidFill>
+                  <a:srgbClr val="253439"/>
+                </a:solidFill>
+                <a:latin typeface="Segoe UI"/>
+              </a:rPr>
+              <a:t>frames</a:t>
+            </a:r>
+            <a:r>
+              <a:rPr sz="1050" b="0" i="0" dirty="0">
+                <a:solidFill>
+                  <a:srgbClr val="253439"/>
+                </a:solidFill>
+                <a:latin typeface="Segoe UI"/>
+              </a:rPr>
+              <a:t> per second</a:t>
+            </a:r>
+            <a:r>
+              <a:rPr lang="en-GB" sz="1050" b="0" i="0" dirty="0">
+                <a:solidFill>
+                  <a:srgbClr val="253439"/>
+                </a:solidFill>
+                <a:latin typeface="Segoe UI"/>
+              </a:rPr>
+              <a:t> (FPS)</a:t>
+            </a:r>
+            <a:r>
+              <a:rPr sz="1050" b="0" i="0" dirty="0">
+                <a:solidFill>
+                  <a:srgbClr val="253439"/>
+                </a:solidFill>
+                <a:latin typeface="Segoe UI"/>
+              </a:rPr>
+              <a:t>, live on screen while the test runs</a:t>
             </a:r>
           </a:p>
         </p:txBody>
@@ -19875,7 +20073,7 @@
           <p:nvPr/>
         </p:nvPicPr>
         <p:blipFill>
-          <a:blip r:embed="rId2"/>
+          <a:blip r:embed="rId3"/>
           <a:stretch>
             <a:fillRect/>
           </a:stretch>
@@ -20372,7 +20570,7 @@
           <p:nvPr/>
         </p:nvPicPr>
         <p:blipFill>
-          <a:blip r:embed="rId3"/>
+          <a:blip r:embed="rId4"/>
           <a:stretch>
             <a:fillRect/>
           </a:stretch>
@@ -20496,7 +20694,7 @@
               </a:spcAft>
             </a:pPr>
             <a:r>
-              <a:rPr sz="1100" b="1" i="0">
+              <a:rPr sz="1100" b="1" i="0" dirty="0">
                 <a:solidFill>
                   <a:srgbClr val="B29E84"/>
                 </a:solidFill>
@@ -20505,13 +20703,31 @@
               <a:t>▪  </a:t>
             </a:r>
             <a:r>
-              <a:rPr sz="1100" b="0" i="0">
+              <a:rPr sz="1100" b="0" i="0" dirty="0">
                 <a:solidFill>
                   <a:srgbClr val="253439"/>
                 </a:solidFill>
                 <a:latin typeface="Segoe UI"/>
               </a:rPr>
-              <a:t>twin ball-screw frame, 4.5 kN load cell</a:t>
+              <a:t>twin ball-screw frame, 4.5 </a:t>
+            </a:r>
+            <a:r>
+              <a:rPr sz="1100" b="0" i="0" dirty="0" err="1">
+                <a:solidFill>
+                  <a:srgbClr val="253439"/>
+                </a:solidFill>
+                <a:latin typeface="Segoe UI"/>
+              </a:rPr>
+              <a:t>kN</a:t>
+            </a:r>
+            <a:r>
+              <a:rPr sz="1100" b="0" i="0" dirty="0">
+                <a:solidFill>
+                  <a:srgbClr val="253439"/>
+                </a:solidFill>
+                <a:latin typeface="Segoe UI"/>
+              </a:rPr>
+              <a:t> load cell</a:t>
             </a:r>
           </a:p>
           <a:p>
@@ -20524,7 +20740,7 @@
               </a:spcAft>
             </a:pPr>
             <a:r>
-              <a:rPr sz="1100" b="1" i="0">
+              <a:rPr sz="1100" b="1" i="0" dirty="0">
                 <a:solidFill>
                   <a:srgbClr val="B29E84"/>
                 </a:solidFill>
@@ -20533,7 +20749,7 @@
               <a:t>▪  </a:t>
             </a:r>
             <a:r>
-              <a:rPr sz="1100" b="0" i="0">
+              <a:rPr sz="1100" b="0" i="0" dirty="0">
                 <a:solidFill>
                   <a:srgbClr val="253439"/>
                 </a:solidFill>
@@ -20552,7 +20768,7 @@
               </a:spcAft>
             </a:pPr>
             <a:r>
-              <a:rPr sz="1100" b="1" i="0">
+              <a:rPr sz="1100" b="1" i="0" dirty="0">
                 <a:solidFill>
                   <a:srgbClr val="B29E84"/>
                 </a:solidFill>
@@ -20561,7 +20777,7 @@
               <a:t>▪  </a:t>
             </a:r>
             <a:r>
-              <a:rPr sz="1100" b="0" i="0">
+              <a:rPr sz="1100" b="0" i="0" dirty="0">
                 <a:solidFill>
                   <a:srgbClr val="253439"/>
                 </a:solidFill>
@@ -20642,7 +20858,7 @@
               </a:spcAft>
             </a:pPr>
             <a:r>
-              <a:rPr sz="1100" b="1" i="0">
+              <a:rPr sz="1100" b="1" i="0" dirty="0">
                 <a:solidFill>
                   <a:srgbClr val="B29E84"/>
                 </a:solidFill>
@@ -20651,7 +20867,7 @@
               <a:t>▪  </a:t>
             </a:r>
             <a:r>
-              <a:rPr sz="1100" b="0" i="0">
+              <a:rPr sz="1100" b="0" i="0" dirty="0">
                 <a:solidFill>
                   <a:srgbClr val="253439"/>
                 </a:solidFill>
@@ -20670,7 +20886,7 @@
               </a:spcAft>
             </a:pPr>
             <a:r>
-              <a:rPr sz="1100" b="1" i="0">
+              <a:rPr sz="1100" b="1" i="0" dirty="0">
                 <a:solidFill>
                   <a:srgbClr val="B29E84"/>
                 </a:solidFill>
@@ -20679,7 +20895,7 @@
               <a:t>▪  </a:t>
             </a:r>
             <a:r>
-              <a:rPr sz="1100" b="0" i="0">
+              <a:rPr sz="1100" b="0" i="0" dirty="0">
                 <a:solidFill>
                   <a:srgbClr val="253439"/>
                 </a:solidFill>
@@ -20698,7 +20914,7 @@
               </a:spcAft>
             </a:pPr>
             <a:r>
-              <a:rPr sz="1100" b="1" i="0">
+              <a:rPr sz="1100" b="1" i="0" dirty="0">
                 <a:solidFill>
                   <a:srgbClr val="B29E84"/>
                 </a:solidFill>
@@ -20707,7 +20923,7 @@
               <a:t>▪  </a:t>
             </a:r>
             <a:r>
-              <a:rPr sz="1100" b="0" i="0">
+              <a:rPr sz="1100" b="0" i="0" dirty="0">
                 <a:solidFill>
                   <a:srgbClr val="253439"/>
                 </a:solidFill>
@@ -20726,7 +20942,7 @@
               </a:spcAft>
             </a:pPr>
             <a:r>
-              <a:rPr sz="1100" b="1" i="0">
+              <a:rPr sz="1100" b="1" i="0" dirty="0">
                 <a:solidFill>
                   <a:srgbClr val="B29E84"/>
                 </a:solidFill>
@@ -20735,7 +20951,7 @@
               <a:t>▪  </a:t>
             </a:r>
             <a:r>
-              <a:rPr sz="1100" b="0" i="0">
+              <a:rPr sz="1100" b="0" i="0" dirty="0">
                 <a:solidFill>
                   <a:srgbClr val="253439"/>
                 </a:solidFill>

</xml_diff>

<commit_message>
Slide 3 speaker note: the glued/clipped/camera mnemonic
First set as the long one-liner, then replaced at his request with the sharper
form: glued = strain gauge, clipped = extensometer, camera = video extensometer
(XT-205, and our rig) - 'your rig' adjusted to 'our rig' since he is the
speaker. Notes are a separate part, so all 19 slides' shapes proved byte-stable
both times; generator synced so a rebuild carries the note.

Co-Authored-By: Claude Fable 5 <noreply@anthropic.com>
</commit_message>
<xml_diff>
--- a/documentation/decks/PPD_Final_Presentation.pptx
+++ b/documentation/decks/PPD_Final_Presentation.pptx
@@ -968,6 +968,76 @@
         <p14:creationId xmlns:p14="http://schemas.microsoft.com/office/powerpoint/2010/main" val="1100821083"/>
       </p:ext>
     </p:extLst>
+  </p:cSld>
+  <p:clrMapOvr>
+    <a:masterClrMapping/>
+  </p:clrMapOvr>
+</p:notes>
+</file>
+
+<file path=ppt/notesSlides/notesSlide3.xml><?xml version="1.0" encoding="utf-8"?>
+<p:notes xmlns:a="http://schemas.openxmlformats.org/drawingml/2006/main" xmlns:p="http://schemas.openxmlformats.org/presentationml/2006/main" xmlns:r="http://schemas.openxmlformats.org/officeDocument/2006/relationships">
+  <p:cSld>
+    <p:spTree>
+      <p:nvGrpSpPr>
+        <p:cNvPr id="1" name=""/>
+        <p:cNvGrpSpPr/>
+        <p:nvPr/>
+      </p:nvGrpSpPr>
+      <p:grpSpPr>
+        <a:xfrm>
+          <a:off x="0" y="0"/>
+          <a:ext cx="0" cy="0"/>
+          <a:chOff x="0" y="0"/>
+          <a:chExt cx="0" cy="0"/>
+        </a:xfrm>
+      </p:grpSpPr>
+      <p:sp>
+        <p:nvSpPr>
+          <p:cNvPr id="2" name="Slide Image Placeholder 1"/>
+          <p:cNvSpPr>
+            <a:spLocks noGrp="1"/>
+          </p:cNvSpPr>
+          <p:nvPr>
+            <p:ph type="sldImg" idx="2"/>
+          </p:nvPr>
+        </p:nvSpPr>
+        <p:spPr/>
+      </p:sp>
+      <p:sp>
+        <p:nvSpPr>
+          <p:cNvPr id="3" name="Notes Placeholder 2"/>
+          <p:cNvSpPr>
+            <a:spLocks noGrp="1"/>
+          </p:cNvSpPr>
+          <p:nvPr>
+            <p:ph type="body" idx="3" sz="quarter"/>
+          </p:nvPr>
+        </p:nvSpPr>
+        <p:spPr/>
+        <p:txBody>
+          <a:bodyPr/>
+          <a:lstStyle/>
+          <a:p>
+            <a:r>
+              <a:t>glued = strain gauge, clipped = extensometer, camera = video extensometer (XT-205, and our rig)</a:t>
+            </a:r>
+          </a:p>
+        </p:txBody>
+      </p:sp>
+      <p:sp>
+        <p:nvSpPr>
+          <p:cNvPr id="4" name="Slide Number Placeholder 3"/>
+          <p:cNvSpPr>
+            <a:spLocks noGrp="1"/>
+          </p:cNvSpPr>
+          <p:nvPr>
+            <p:ph type="sldNum" idx="5" sz="quarter"/>
+          </p:nvPr>
+        </p:nvSpPr>
+        <p:spPr/>
+      </p:sp>
+    </p:spTree>
   </p:cSld>
   <p:clrMapOvr>
     <a:masterClrMapping/>

</xml_diff>